<commit_message>
Update group-analysis results (n=10), deck, and test104/109 Pkmas data
- Regenerated Results/Group Analysis outputs (SPSS, Summary, Results.md,
  .mat, figures) for the current n=10 cohort.
- Updated 2026-10-26 statistical-analysis deck.
- Added Pkmas data for test104 and test109.

Co-Authored-By: Claude Opus 4.8 <noreply@anthropic.com>
</commit_message>
<xml_diff>
--- a/Presentations/26-10-26-group-meeting-statistical-analysis-101-109.pptx
+++ b/Presentations/26-10-26-group-meeting-statistical-analysis-101-109.pptx
@@ -12,6 +12,10 @@
     <p:sldId id="257" r:id="rId6"/>
     <p:sldId id="260" r:id="rId7"/>
     <p:sldId id="261" r:id="rId8"/>
+    <p:sldId id="264" r:id="rId9"/>
+    <p:sldId id="265" r:id="rId10"/>
+    <p:sldId id="266" r:id="rId11"/>
+    <p:sldId id="267" r:id="rId12"/>
   </p:sldIdLst>
   <p:sldSz cx="15125700" cy="10693400"/>
   <p:notesSz cx="15125700" cy="10693400"/>
@@ -13627,6 +13631,429 @@
 </p:sld>
 </file>
 
+<file path=ppt/slides/slide10.xml><?xml version="1.0" encoding="utf-8"?>
+<p:sld xmlns:a="http://schemas.openxmlformats.org/drawingml/2006/main" xmlns:r="http://schemas.openxmlformats.org/officeDocument/2006/relationships" xmlns:p="http://schemas.openxmlformats.org/presentationml/2006/main">
+  <p:cSld>
+    <p:spTree>
+      <p:nvGrpSpPr>
+        <p:cNvPr id="1" name=""/>
+        <p:cNvGrpSpPr/>
+        <p:nvPr/>
+      </p:nvGrpSpPr>
+      <p:grpSpPr>
+        <a:xfrm>
+          <a:off x="0" y="0"/>
+          <a:ext cx="0" cy="0"/>
+          <a:chOff x="0" y="0"/>
+          <a:chExt cx="0" cy="0"/>
+        </a:xfrm>
+      </p:grpSpPr>
+      <p:sp>
+        <p:nvSpPr>
+          <p:cNvPr id="2" name="TextBox 1"/>
+          <p:cNvSpPr txBox="1"/>
+          <p:nvPr/>
+        </p:nvSpPr>
+        <p:spPr>
+          <a:xfrm>
+            <a:off x="850821" y="1603090"/>
+            <a:ext cx="5245347" cy="646331"/>
+          </a:xfrm>
+          <a:prstGeom prst="rect">
+            <a:avLst/>
+          </a:prstGeom>
+          <a:noFill/>
+        </p:spPr>
+        <p:txBody>
+          <a:bodyPr wrap="none">
+            <a:spAutoFit/>
+          </a:bodyPr>
+          <a:lstStyle/>
+          <a:p>
+            <a:pPr>
+              <a:defRPr sz="2800" b="1">
+                <a:solidFill>
+                  <a:srgbClr val="1F344F"/>
+                </a:solidFill>
+                <a:latin typeface="Aptos Display"/>
+              </a:defRPr>
+            </a:pPr>
+            <a:r>
+              <a:rPr sz="3600"/>
+              <a:t>How We Can Use the Idea</a:t>
+            </a:r>
+          </a:p>
+        </p:txBody>
+      </p:sp>
+      <p:sp>
+        <p:nvSpPr>
+          <p:cNvPr id="4" name="TextBox 3"/>
+          <p:cNvSpPr txBox="1"/>
+          <p:nvPr/>
+        </p:nvSpPr>
+        <p:spPr>
+          <a:xfrm>
+            <a:off x="1020985" y="3043812"/>
+            <a:ext cx="13045916" cy="3970318"/>
+          </a:xfrm>
+          <a:prstGeom prst="rect">
+            <a:avLst/>
+          </a:prstGeom>
+          <a:noFill/>
+        </p:spPr>
+        <p:txBody>
+          <a:bodyPr wrap="square">
+            <a:spAutoFit/>
+          </a:bodyPr>
+          <a:lstStyle/>
+          <a:p>
+            <a:pPr>
+              <a:spcAft>
+                <a:spcPts val="1117"/>
+              </a:spcAft>
+              <a:defRPr sz="2000">
+                <a:solidFill>
+                  <a:srgbClr val="232323"/>
+                </a:solidFill>
+                <a:latin typeface="Aptos"/>
+              </a:defRPr>
+            </a:pPr>
+            <a:r>
+              <a:rPr sz="2800"/>
+              <a:t>Our current question: obstacle height/width → how does movement change?</a:t>
+            </a:r>
+          </a:p>
+          <a:p>
+            <a:pPr>
+              <a:spcAft>
+                <a:spcPts val="1117"/>
+              </a:spcAft>
+              <a:defRPr sz="2000">
+                <a:solidFill>
+                  <a:srgbClr val="232323"/>
+                </a:solidFill>
+                <a:latin typeface="Aptos"/>
+              </a:defRPr>
+            </a:pPr>
+            <a:r>
+              <a:rPr sz="2800"/>
+              <a:t>TERRA-inspired reverse question: movement → what obstacle or task demand was present?</a:t>
+            </a:r>
+          </a:p>
+          <a:p>
+            <a:pPr>
+              <a:spcAft>
+                <a:spcPts val="1117"/>
+              </a:spcAft>
+              <a:defRPr sz="2000">
+                <a:solidFill>
+                  <a:srgbClr val="232323"/>
+                </a:solidFill>
+                <a:latin typeface="Aptos"/>
+              </a:defRPr>
+            </a:pPr>
+            <a:r>
+              <a:rPr sz="2800"/>
+              <a:t>Possible inputs:</a:t>
+            </a:r>
+          </a:p>
+          <a:p>
+            <a:pPr lvl="1">
+              <a:spcAft>
+                <a:spcPts val="496"/>
+              </a:spcAft>
+              <a:defRPr sz="1800">
+                <a:solidFill>
+                  <a:srgbClr val="232323"/>
+                </a:solidFill>
+                <a:latin typeface="Aptos"/>
+              </a:defRPr>
+            </a:pPr>
+            <a:r>
+              <a:rPr sz="2400"/>
+              <a:t>Thigh, shank, and foot segment angles</a:t>
+            </a:r>
+          </a:p>
+          <a:p>
+            <a:pPr lvl="1">
+              <a:spcAft>
+                <a:spcPts val="496"/>
+              </a:spcAft>
+              <a:defRPr sz="1800">
+                <a:solidFill>
+                  <a:srgbClr val="232323"/>
+                </a:solidFill>
+                <a:latin typeface="Aptos"/>
+              </a:defRPr>
+            </a:pPr>
+            <a:r>
+              <a:rPr sz="2400"/>
+              <a:t>Hip, knee, and ankle joint angles</a:t>
+            </a:r>
+          </a:p>
+          <a:p>
+            <a:pPr lvl="1">
+              <a:spcAft>
+                <a:spcPts val="496"/>
+              </a:spcAft>
+              <a:defRPr sz="1800">
+                <a:solidFill>
+                  <a:srgbClr val="232323"/>
+                </a:solidFill>
+                <a:latin typeface="Aptos"/>
+              </a:defRPr>
+            </a:pPr>
+            <a:r>
+              <a:rPr sz="2400"/>
+              <a:t>Toe clearance, takeoff/landing distance, timing, leading/trailing limb</a:t>
+            </a:r>
+          </a:p>
+          <a:p>
+            <a:pPr>
+              <a:spcAft>
+                <a:spcPts val="1117"/>
+              </a:spcAft>
+              <a:defRPr sz="2000">
+                <a:solidFill>
+                  <a:srgbClr val="232323"/>
+                </a:solidFill>
+                <a:latin typeface="Aptos"/>
+              </a:defRPr>
+            </a:pPr>
+            <a:r>
+              <a:rPr sz="2800"/>
+              <a:t>Possible outputs: </a:t>
+            </a:r>
+            <a:r>
+              <a:rPr sz="2800">
+                <a:solidFill>
+                  <a:srgbClr val="FF0000"/>
+                </a:solidFill>
+              </a:rPr>
+              <a:t>obstacle condition, height, width, or challenge level</a:t>
+            </a:r>
+            <a:r>
+              <a:rPr sz="2800"/>
+              <a:t>.</a:t>
+            </a:r>
+          </a:p>
+        </p:txBody>
+      </p:sp>
+    </p:spTree>
+  </p:cSld>
+  <p:clrMapOvr>
+    <a:masterClrMapping/>
+  </p:clrMapOvr>
+</p:sld>
+</file>
+
+<file path=ppt/slides/slide11.xml><?xml version="1.0" encoding="utf-8"?>
+<p:sld xmlns:a="http://schemas.openxmlformats.org/drawingml/2006/main" xmlns:r="http://schemas.openxmlformats.org/officeDocument/2006/relationships" xmlns:p="http://schemas.openxmlformats.org/presentationml/2006/main">
+  <p:cSld>
+    <p:spTree>
+      <p:nvGrpSpPr>
+        <p:cNvPr id="1" name=""/>
+        <p:cNvGrpSpPr/>
+        <p:nvPr/>
+      </p:nvGrpSpPr>
+      <p:grpSpPr>
+        <a:xfrm>
+          <a:off x="0" y="0"/>
+          <a:ext cx="0" cy="0"/>
+          <a:chOff x="0" y="0"/>
+          <a:chExt cx="0" cy="0"/>
+        </a:xfrm>
+      </p:grpSpPr>
+      <p:sp>
+        <p:nvSpPr>
+          <p:cNvPr id="2" name="TextBox 1"/>
+          <p:cNvSpPr txBox="1"/>
+          <p:nvPr/>
+        </p:nvSpPr>
+        <p:spPr>
+          <a:xfrm>
+            <a:off x="850821" y="1603090"/>
+            <a:ext cx="6418745" cy="646331"/>
+          </a:xfrm>
+          <a:prstGeom prst="rect">
+            <a:avLst/>
+          </a:prstGeom>
+          <a:noFill/>
+        </p:spPr>
+        <p:txBody>
+          <a:bodyPr wrap="none">
+            <a:spAutoFit/>
+          </a:bodyPr>
+          <a:lstStyle/>
+          <a:p>
+            <a:pPr>
+              <a:defRPr sz="2800" b="1">
+                <a:solidFill>
+                  <a:srgbClr val="1F344F"/>
+                </a:solidFill>
+                <a:latin typeface="Aptos Display"/>
+              </a:defRPr>
+            </a:pPr>
+            <a:r>
+              <a:rPr sz="3600"/>
+              <a:t>What Our Project Could Answer</a:t>
+            </a:r>
+          </a:p>
+        </p:txBody>
+      </p:sp>
+      <p:sp>
+        <p:nvSpPr>
+          <p:cNvPr id="4" name="TextBox 3"/>
+          <p:cNvSpPr txBox="1"/>
+          <p:nvPr/>
+        </p:nvSpPr>
+        <p:spPr>
+          <a:xfrm>
+            <a:off x="1020985" y="3077845"/>
+            <a:ext cx="13045916" cy="3241913"/>
+          </a:xfrm>
+          <a:prstGeom prst="rect">
+            <a:avLst/>
+          </a:prstGeom>
+          <a:noFill/>
+        </p:spPr>
+        <p:txBody>
+          <a:bodyPr wrap="square">
+            <a:spAutoFit/>
+          </a:bodyPr>
+          <a:lstStyle/>
+          <a:p>
+            <a:pPr>
+              <a:spcAft>
+                <a:spcPts val="1117"/>
+              </a:spcAft>
+              <a:defRPr sz="2100">
+                <a:solidFill>
+                  <a:srgbClr val="232323"/>
+                </a:solidFill>
+                <a:latin typeface="Aptos"/>
+              </a:defRPr>
+            </a:pPr>
+            <a:r>
+              <a:rPr sz="2800"/>
+              <a:t>Can obstacle height or width be predicted from IMU-derived kinematics?</a:t>
+            </a:r>
+          </a:p>
+          <a:p>
+            <a:pPr>
+              <a:spcAft>
+                <a:spcPts val="1117"/>
+              </a:spcAft>
+              <a:defRPr sz="2100">
+                <a:solidFill>
+                  <a:srgbClr val="232323"/>
+                </a:solidFill>
+                <a:latin typeface="Aptos"/>
+              </a:defRPr>
+            </a:pPr>
+            <a:r>
+              <a:rPr sz="2800"/>
+              <a:t>Which variables best explain the crossing strategy: segment angles, joint angles, or foot placement?</a:t>
+            </a:r>
+          </a:p>
+          <a:p>
+            <a:pPr>
+              <a:spcAft>
+                <a:spcPts val="1117"/>
+              </a:spcAft>
+              <a:defRPr sz="2100">
+                <a:solidFill>
+                  <a:srgbClr val="232323"/>
+                </a:solidFill>
+                <a:latin typeface="Aptos"/>
+              </a:defRPr>
+            </a:pPr>
+            <a:r>
+              <a:rPr sz="2800"/>
+              <a:t>Can we distinguish leading- and trailing-limb strategies automatically?</a:t>
+            </a:r>
+          </a:p>
+          <a:p>
+            <a:pPr>
+              <a:spcAft>
+                <a:spcPts val="1117"/>
+              </a:spcAft>
+              <a:defRPr sz="2100">
+                <a:solidFill>
+                  <a:srgbClr val="232323"/>
+                </a:solidFill>
+                <a:latin typeface="Aptos"/>
+              </a:defRPr>
+            </a:pPr>
+            <a:r>
+              <a:rPr sz="2800"/>
+              <a:t>How much sensing is really needed: IMU-only vs camera/OpenSim + IMU?</a:t>
+            </a:r>
+          </a:p>
+          <a:p>
+            <a:pPr>
+              <a:spcAft>
+                <a:spcPts val="1117"/>
+              </a:spcAft>
+              <a:defRPr sz="2100">
+                <a:solidFill>
+                  <a:srgbClr val="232323"/>
+                </a:solidFill>
+                <a:latin typeface="Aptos"/>
+              </a:defRPr>
+            </a:pPr>
+            <a:r>
+              <a:rPr sz="2800"/>
+              <a:t>Can the inferred task demand be used later for context-aware haptic feedback?</a:t>
+            </a:r>
+          </a:p>
+        </p:txBody>
+      </p:sp>
+      <p:sp>
+        <p:nvSpPr>
+          <p:cNvPr id="5" name="TextBox 4"/>
+          <p:cNvSpPr txBox="1"/>
+          <p:nvPr/>
+        </p:nvSpPr>
+        <p:spPr>
+          <a:xfrm>
+            <a:off x="1020986" y="6583736"/>
+            <a:ext cx="9641997" cy="1200329"/>
+          </a:xfrm>
+          <a:prstGeom prst="rect">
+            <a:avLst/>
+          </a:prstGeom>
+          <a:noFill/>
+        </p:spPr>
+        <p:txBody>
+          <a:bodyPr wrap="square">
+            <a:spAutoFit/>
+          </a:bodyPr>
+          <a:lstStyle/>
+          <a:p>
+            <a:pPr>
+              <a:defRPr sz="1700" b="1">
+                <a:solidFill>
+                  <a:srgbClr val="1F344F"/>
+                </a:solidFill>
+                <a:latin typeface="Aptos"/>
+              </a:defRPr>
+            </a:pPr>
+            <a:r>
+              <a:rPr sz="2400"/>
+              <a:t>Practical first step: build a participant × obstacle × repetition dataset and test obstacle-condition classification/regression before attempting full simulation.</a:t>
+            </a:r>
+          </a:p>
+        </p:txBody>
+      </p:sp>
+    </p:spTree>
+  </p:cSld>
+  <p:clrMapOvr>
+    <a:masterClrMapping/>
+  </p:clrMapOvr>
+</p:sld>
+</file>
+
 <file path=ppt/slides/slide2.xml><?xml version="1.0" encoding="utf-8"?>
 <p:sld xmlns:a="http://schemas.openxmlformats.org/drawingml/2006/main" xmlns:r="http://schemas.openxmlformats.org/officeDocument/2006/relationships" xmlns:p="http://schemas.openxmlformats.org/presentationml/2006/main">
   <p:cSld>
@@ -14053,6 +14480,664 @@
 </p:sld>
 </file>
 
+<file path=ppt/slides/slide8.xml><?xml version="1.0" encoding="utf-8"?>
+<p:sld xmlns:a="http://schemas.openxmlformats.org/drawingml/2006/main" xmlns:r="http://schemas.openxmlformats.org/officeDocument/2006/relationships" xmlns:p="http://schemas.openxmlformats.org/presentationml/2006/main">
+  <p:cSld>
+    <p:spTree>
+      <p:nvGrpSpPr>
+        <p:cNvPr id="1" name=""/>
+        <p:cNvGrpSpPr/>
+        <p:nvPr/>
+      </p:nvGrpSpPr>
+      <p:grpSpPr>
+        <a:xfrm>
+          <a:off x="0" y="0"/>
+          <a:ext cx="0" cy="0"/>
+          <a:chOff x="0" y="0"/>
+          <a:chExt cx="0" cy="0"/>
+        </a:xfrm>
+      </p:grpSpPr>
+      <p:sp>
+        <p:nvSpPr>
+          <p:cNvPr id="2" name="TextBox 1"/>
+          <p:cNvSpPr txBox="1"/>
+          <p:nvPr/>
+        </p:nvSpPr>
+        <p:spPr>
+          <a:xfrm>
+            <a:off x="850821" y="1603090"/>
+            <a:ext cx="9005992" cy="646331"/>
+          </a:xfrm>
+          <a:prstGeom prst="rect">
+            <a:avLst/>
+          </a:prstGeom>
+          <a:noFill/>
+        </p:spPr>
+        <p:txBody>
+          <a:bodyPr wrap="none">
+            <a:spAutoFit/>
+          </a:bodyPr>
+          <a:lstStyle/>
+          <a:p>
+            <a:pPr>
+              <a:defRPr sz="2800" b="1">
+                <a:solidFill>
+                  <a:srgbClr val="1F344F"/>
+                </a:solidFill>
+                <a:latin typeface="Aptos Display"/>
+              </a:defRPr>
+            </a:pPr>
+            <a:r>
+              <a:rPr sz="3600"/>
+              <a:t>TERRA-Inspired Obstacle-Crossing Research</a:t>
+            </a:r>
+          </a:p>
+        </p:txBody>
+      </p:sp>
+      <p:sp>
+        <p:nvSpPr>
+          <p:cNvPr id="5" name="TextBox 4"/>
+          <p:cNvSpPr txBox="1"/>
+          <p:nvPr/>
+        </p:nvSpPr>
+        <p:spPr>
+          <a:xfrm>
+            <a:off x="586061" y="3501511"/>
+            <a:ext cx="13714504" cy="1901546"/>
+          </a:xfrm>
+          <a:prstGeom prst="rect">
+            <a:avLst/>
+          </a:prstGeom>
+          <a:noFill/>
+        </p:spPr>
+        <p:txBody>
+          <a:bodyPr wrap="square">
+            <a:spAutoFit/>
+          </a:bodyPr>
+          <a:lstStyle/>
+          <a:p>
+            <a:pPr marL="425402" indent="-425402">
+              <a:spcAft>
+                <a:spcPts val="1117"/>
+              </a:spcAft>
+              <a:buFont typeface="Arial" panose="020B0604020202020204" pitchFamily="34" charset="0"/>
+              <a:buChar char="•"/>
+              <a:defRPr sz="2400">
+                <a:solidFill>
+                  <a:srgbClr val="232323"/>
+                </a:solidFill>
+                <a:latin typeface="Aptos"/>
+              </a:defRPr>
+            </a:pPr>
+            <a:r>
+              <a:rPr sz="2481"/>
+              <a:t>TERRA asks: </a:t>
+            </a:r>
+            <a:r>
+              <a:rPr lang="en-US" sz="2481"/>
+              <a:t>Can</a:t>
+            </a:r>
+            <a:r>
+              <a:rPr sz="2481"/>
+              <a:t> the environment be reconstructed from human movement alone?</a:t>
+            </a:r>
+          </a:p>
+          <a:p>
+            <a:pPr marL="425402" indent="-425402">
+              <a:spcAft>
+                <a:spcPts val="1117"/>
+              </a:spcAft>
+              <a:buFont typeface="Arial" panose="020B0604020202020204" pitchFamily="34" charset="0"/>
+              <a:buChar char="•"/>
+              <a:defRPr sz="2400">
+                <a:solidFill>
+                  <a:srgbClr val="232323"/>
+                </a:solidFill>
+                <a:latin typeface="Aptos"/>
+              </a:defRPr>
+            </a:pPr>
+            <a:r>
+              <a:rPr sz="2481"/>
+              <a:t>Our opportunity: can obstacle properties be inferred from lower-limb kinematics?</a:t>
+            </a:r>
+          </a:p>
+          <a:p>
+            <a:pPr marL="425402" indent="-425402">
+              <a:spcAft>
+                <a:spcPts val="1117"/>
+              </a:spcAft>
+              <a:buFont typeface="Arial" panose="020B0604020202020204" pitchFamily="34" charset="0"/>
+              <a:buChar char="•"/>
+              <a:defRPr sz="2400">
+                <a:solidFill>
+                  <a:srgbClr val="232323"/>
+                </a:solidFill>
+                <a:latin typeface="Aptos"/>
+              </a:defRPr>
+            </a:pPr>
+            <a:r>
+              <a:rPr sz="2481"/>
+              <a:t>This creates a bridge between biomechanics, wearable sensing, computer vision, and intelligent feedback.</a:t>
+            </a:r>
+          </a:p>
+        </p:txBody>
+      </p:sp>
+      <p:sp>
+        <p:nvSpPr>
+          <p:cNvPr id="6" name="TextBox 5"/>
+          <p:cNvSpPr txBox="1"/>
+          <p:nvPr/>
+        </p:nvSpPr>
+        <p:spPr>
+          <a:xfrm>
+            <a:off x="586061" y="5863464"/>
+            <a:ext cx="2347117" cy="400110"/>
+          </a:xfrm>
+          <a:prstGeom prst="rect">
+            <a:avLst/>
+          </a:prstGeom>
+          <a:noFill/>
+        </p:spPr>
+        <p:txBody>
+          <a:bodyPr wrap="none">
+            <a:spAutoFit/>
+          </a:bodyPr>
+          <a:lstStyle/>
+          <a:p>
+            <a:pPr algn="ctr">
+              <a:defRPr sz="1500" b="1">
+                <a:solidFill>
+                  <a:srgbClr val="1F344F"/>
+                </a:solidFill>
+                <a:latin typeface="Aptos"/>
+              </a:defRPr>
+            </a:pPr>
+            <a:r>
+              <a:rPr sz="2000"/>
+              <a:t>Human movement</a:t>
+            </a:r>
+          </a:p>
+        </p:txBody>
+      </p:sp>
+      <p:sp>
+        <p:nvSpPr>
+          <p:cNvPr id="7" name="Right Arrow 6"/>
+          <p:cNvSpPr/>
+          <p:nvPr/>
+        </p:nvSpPr>
+        <p:spPr>
+          <a:xfrm>
+            <a:off x="3034874" y="5954217"/>
+            <a:ext cx="907542" cy="283607"/>
+          </a:xfrm>
+          <a:prstGeom prst="rightArrow">
+            <a:avLst/>
+          </a:prstGeom>
+          <a:solidFill>
+            <a:srgbClr val="5F5F5F"/>
+          </a:solidFill>
+          <a:ln>
+            <a:noFill/>
+          </a:ln>
+        </p:spPr>
+        <p:style>
+          <a:lnRef idx="1">
+            <a:schemeClr val="accent1"/>
+          </a:lnRef>
+          <a:fillRef idx="3">
+            <a:schemeClr val="accent1"/>
+          </a:fillRef>
+          <a:effectRef idx="2">
+            <a:schemeClr val="accent1"/>
+          </a:effectRef>
+          <a:fontRef idx="minor">
+            <a:schemeClr val="lt1"/>
+          </a:fontRef>
+        </p:style>
+        <p:txBody>
+          <a:bodyPr rtlCol="0" anchor="ctr"/>
+          <a:lstStyle/>
+          <a:p>
+            <a:pPr algn="ctr"/>
+            <a:endParaRPr sz="2000"/>
+          </a:p>
+        </p:txBody>
+      </p:sp>
+      <p:sp>
+        <p:nvSpPr>
+          <p:cNvPr id="8" name="TextBox 7"/>
+          <p:cNvSpPr txBox="1"/>
+          <p:nvPr/>
+        </p:nvSpPr>
+        <p:spPr>
+          <a:xfrm>
+            <a:off x="4408526" y="5863464"/>
+            <a:ext cx="1508747" cy="400110"/>
+          </a:xfrm>
+          <a:prstGeom prst="rect">
+            <a:avLst/>
+          </a:prstGeom>
+          <a:noFill/>
+        </p:spPr>
+        <p:txBody>
+          <a:bodyPr wrap="none">
+            <a:spAutoFit/>
+          </a:bodyPr>
+          <a:lstStyle/>
+          <a:p>
+            <a:pPr algn="ctr">
+              <a:defRPr sz="1500" b="1">
+                <a:solidFill>
+                  <a:srgbClr val="1F344F"/>
+                </a:solidFill>
+                <a:latin typeface="Aptos"/>
+              </a:defRPr>
+            </a:pPr>
+            <a:r>
+              <a:rPr sz="2000"/>
+              <a:t>Kinematics</a:t>
+            </a:r>
+          </a:p>
+        </p:txBody>
+      </p:sp>
+      <p:sp>
+        <p:nvSpPr>
+          <p:cNvPr id="9" name="Right Arrow 8"/>
+          <p:cNvSpPr/>
+          <p:nvPr/>
+        </p:nvSpPr>
+        <p:spPr>
+          <a:xfrm>
+            <a:off x="6315533" y="5921715"/>
+            <a:ext cx="907542" cy="283607"/>
+          </a:xfrm>
+          <a:prstGeom prst="rightArrow">
+            <a:avLst/>
+          </a:prstGeom>
+          <a:solidFill>
+            <a:srgbClr val="5F5F5F"/>
+          </a:solidFill>
+          <a:ln>
+            <a:noFill/>
+          </a:ln>
+        </p:spPr>
+        <p:style>
+          <a:lnRef idx="1">
+            <a:schemeClr val="accent1"/>
+          </a:lnRef>
+          <a:fillRef idx="3">
+            <a:schemeClr val="accent1"/>
+          </a:fillRef>
+          <a:effectRef idx="2">
+            <a:schemeClr val="accent1"/>
+          </a:effectRef>
+          <a:fontRef idx="minor">
+            <a:schemeClr val="lt1"/>
+          </a:fontRef>
+        </p:style>
+        <p:txBody>
+          <a:bodyPr rtlCol="0" anchor="ctr"/>
+          <a:lstStyle/>
+          <a:p>
+            <a:pPr algn="ctr"/>
+            <a:endParaRPr sz="2000"/>
+          </a:p>
+        </p:txBody>
+      </p:sp>
+      <p:sp>
+        <p:nvSpPr>
+          <p:cNvPr id="10" name="TextBox 9"/>
+          <p:cNvSpPr txBox="1"/>
+          <p:nvPr/>
+        </p:nvSpPr>
+        <p:spPr>
+          <a:xfrm>
+            <a:off x="7375816" y="5837714"/>
+            <a:ext cx="2419252" cy="400110"/>
+          </a:xfrm>
+          <a:prstGeom prst="rect">
+            <a:avLst/>
+          </a:prstGeom>
+          <a:noFill/>
+        </p:spPr>
+        <p:txBody>
+          <a:bodyPr wrap="none">
+            <a:spAutoFit/>
+          </a:bodyPr>
+          <a:lstStyle/>
+          <a:p>
+            <a:pPr algn="ctr">
+              <a:defRPr sz="1500" b="1">
+                <a:solidFill>
+                  <a:srgbClr val="1F344F"/>
+                </a:solidFill>
+                <a:latin typeface="Aptos"/>
+              </a:defRPr>
+            </a:pPr>
+            <a:r>
+              <a:rPr sz="2000"/>
+              <a:t>Obstacle inference</a:t>
+            </a:r>
+          </a:p>
+        </p:txBody>
+      </p:sp>
+      <p:sp>
+        <p:nvSpPr>
+          <p:cNvPr id="11" name="Right Arrow 10"/>
+          <p:cNvSpPr/>
+          <p:nvPr/>
+        </p:nvSpPr>
+        <p:spPr>
+          <a:xfrm>
+            <a:off x="9985646" y="5921715"/>
+            <a:ext cx="907542" cy="283607"/>
+          </a:xfrm>
+          <a:prstGeom prst="rightArrow">
+            <a:avLst/>
+          </a:prstGeom>
+          <a:solidFill>
+            <a:srgbClr val="5F5F5F"/>
+          </a:solidFill>
+          <a:ln>
+            <a:noFill/>
+          </a:ln>
+        </p:spPr>
+        <p:style>
+          <a:lnRef idx="1">
+            <a:schemeClr val="accent1"/>
+          </a:lnRef>
+          <a:fillRef idx="3">
+            <a:schemeClr val="accent1"/>
+          </a:fillRef>
+          <a:effectRef idx="2">
+            <a:schemeClr val="accent1"/>
+          </a:effectRef>
+          <a:fontRef idx="minor">
+            <a:schemeClr val="lt1"/>
+          </a:fontRef>
+        </p:style>
+        <p:txBody>
+          <a:bodyPr rtlCol="0" anchor="ctr"/>
+          <a:lstStyle/>
+          <a:p>
+            <a:pPr algn="ctr"/>
+            <a:endParaRPr sz="2000"/>
+          </a:p>
+        </p:txBody>
+      </p:sp>
+      <p:sp>
+        <p:nvSpPr>
+          <p:cNvPr id="12" name="TextBox 11"/>
+          <p:cNvSpPr txBox="1"/>
+          <p:nvPr/>
+        </p:nvSpPr>
+        <p:spPr>
+          <a:xfrm>
+            <a:off x="11083767" y="5863464"/>
+            <a:ext cx="2678938" cy="400110"/>
+          </a:xfrm>
+          <a:prstGeom prst="rect">
+            <a:avLst/>
+          </a:prstGeom>
+          <a:noFill/>
+        </p:spPr>
+        <p:txBody>
+          <a:bodyPr wrap="none">
+            <a:spAutoFit/>
+          </a:bodyPr>
+          <a:lstStyle/>
+          <a:p>
+            <a:pPr algn="ctr">
+              <a:defRPr sz="1500" b="1">
+                <a:solidFill>
+                  <a:srgbClr val="1F344F"/>
+                </a:solidFill>
+                <a:latin typeface="Aptos"/>
+              </a:defRPr>
+            </a:pPr>
+            <a:r>
+              <a:rPr lang="en-US" sz="2000"/>
+              <a:t>Feedback/simulation</a:t>
+            </a:r>
+            <a:endParaRPr sz="2000"/>
+          </a:p>
+        </p:txBody>
+      </p:sp>
+      <p:sp>
+        <p:nvSpPr>
+          <p:cNvPr id="4" name="TextBox 3">
+            <a:extLst>
+              <a:ext uri="{FF2B5EF4-FFF2-40B4-BE49-F238E27FC236}">
+                <a16:creationId xmlns:a16="http://schemas.microsoft.com/office/drawing/2014/main" id="{0C44F001-87BA-DDE6-E478-E2B3EC17B707}"/>
+              </a:ext>
+            </a:extLst>
+          </p:cNvPr>
+          <p:cNvSpPr txBox="1"/>
+          <p:nvPr/>
+        </p:nvSpPr>
+        <p:spPr>
+          <a:xfrm>
+            <a:off x="928332" y="2277361"/>
+            <a:ext cx="12963805" cy="523220"/>
+          </a:xfrm>
+          <a:prstGeom prst="rect">
+            <a:avLst/>
+          </a:prstGeom>
+          <a:noFill/>
+        </p:spPr>
+        <p:txBody>
+          <a:bodyPr wrap="none">
+            <a:spAutoFit/>
+          </a:bodyPr>
+          <a:lstStyle/>
+          <a:p>
+            <a:pPr>
+              <a:defRPr sz="2800" b="1">
+                <a:solidFill>
+                  <a:srgbClr val="1F344F"/>
+                </a:solidFill>
+                <a:latin typeface="Aptos Display"/>
+              </a:defRPr>
+            </a:pPr>
+            <a:r>
+              <a:rPr lang="en-US" sz="2800"/>
+              <a:t>Terrain-Aware Reconstruction, Retargeting and Control Musculoskeletal Locomotion</a:t>
+            </a:r>
+            <a:endParaRPr sz="2800"/>
+          </a:p>
+        </p:txBody>
+      </p:sp>
+    </p:spTree>
+  </p:cSld>
+  <p:clrMapOvr>
+    <a:masterClrMapping/>
+  </p:clrMapOvr>
+</p:sld>
+</file>
+
+<file path=ppt/slides/slide9.xml><?xml version="1.0" encoding="utf-8"?>
+<p:sld xmlns:a="http://schemas.openxmlformats.org/drawingml/2006/main" xmlns:r="http://schemas.openxmlformats.org/officeDocument/2006/relationships" xmlns:p="http://schemas.openxmlformats.org/presentationml/2006/main">
+  <p:cSld>
+    <p:spTree>
+      <p:nvGrpSpPr>
+        <p:cNvPr id="1" name=""/>
+        <p:cNvGrpSpPr/>
+        <p:nvPr/>
+      </p:nvGrpSpPr>
+      <p:grpSpPr>
+        <a:xfrm>
+          <a:off x="0" y="0"/>
+          <a:ext cx="0" cy="0"/>
+          <a:chOff x="0" y="0"/>
+          <a:chExt cx="0" cy="0"/>
+        </a:xfrm>
+      </p:grpSpPr>
+      <p:sp>
+        <p:nvSpPr>
+          <p:cNvPr id="2" name="TextBox 1"/>
+          <p:cNvSpPr txBox="1"/>
+          <p:nvPr/>
+        </p:nvSpPr>
+        <p:spPr>
+          <a:xfrm>
+            <a:off x="850820" y="1726963"/>
+            <a:ext cx="3882794" cy="646331"/>
+          </a:xfrm>
+          <a:prstGeom prst="rect">
+            <a:avLst/>
+          </a:prstGeom>
+          <a:noFill/>
+        </p:spPr>
+        <p:txBody>
+          <a:bodyPr wrap="none">
+            <a:spAutoFit/>
+          </a:bodyPr>
+          <a:lstStyle/>
+          <a:p>
+            <a:pPr>
+              <a:defRPr sz="2800" b="1">
+                <a:solidFill>
+                  <a:srgbClr val="1F344F"/>
+                </a:solidFill>
+                <a:latin typeface="Aptos Display"/>
+              </a:defRPr>
+            </a:pPr>
+            <a:r>
+              <a:rPr sz="3600"/>
+              <a:t>How TERRA Works</a:t>
+            </a:r>
+          </a:p>
+        </p:txBody>
+      </p:sp>
+      <p:sp>
+        <p:nvSpPr>
+          <p:cNvPr id="4" name="TextBox 3"/>
+          <p:cNvSpPr txBox="1"/>
+          <p:nvPr/>
+        </p:nvSpPr>
+        <p:spPr>
+          <a:xfrm>
+            <a:off x="836798" y="2549423"/>
+            <a:ext cx="13045916" cy="3531736"/>
+          </a:xfrm>
+          <a:prstGeom prst="rect">
+            <a:avLst/>
+          </a:prstGeom>
+          <a:noFill/>
+        </p:spPr>
+        <p:txBody>
+          <a:bodyPr wrap="square">
+            <a:spAutoFit/>
+          </a:bodyPr>
+          <a:lstStyle/>
+          <a:p>
+            <a:pPr>
+              <a:spcAft>
+                <a:spcPts val="1117"/>
+              </a:spcAft>
+              <a:defRPr sz="2100">
+                <a:solidFill>
+                  <a:srgbClr val="232323"/>
+                </a:solidFill>
+                <a:latin typeface="Aptos"/>
+              </a:defRPr>
+            </a:pPr>
+            <a:r>
+              <a:rPr sz="2800"/>
+              <a:t>1. Start with recorded human motion: body or marker trajectories.</a:t>
+            </a:r>
+          </a:p>
+          <a:p>
+            <a:pPr>
+              <a:spcAft>
+                <a:spcPts val="1117"/>
+              </a:spcAft>
+              <a:defRPr sz="2100">
+                <a:solidFill>
+                  <a:srgbClr val="232323"/>
+                </a:solidFill>
+                <a:latin typeface="Aptos"/>
+              </a:defRPr>
+            </a:pPr>
+            <a:r>
+              <a:rPr sz="2800"/>
+              <a:t>2. Infer task-relevant terrain using estimated contacts, support surfaces, and free-space constraints.</a:t>
+            </a:r>
+          </a:p>
+          <a:p>
+            <a:pPr>
+              <a:spcAft>
+                <a:spcPts val="1117"/>
+              </a:spcAft>
+              <a:defRPr sz="2100">
+                <a:solidFill>
+                  <a:srgbClr val="232323"/>
+                </a:solidFill>
+                <a:latin typeface="Aptos"/>
+              </a:defRPr>
+            </a:pPr>
+            <a:r>
+              <a:rPr sz="2800"/>
+              <a:t>3. Retarget the motion to a musculoskeletal model while respecting anatomy and contact.</a:t>
+            </a:r>
+          </a:p>
+          <a:p>
+            <a:pPr>
+              <a:spcAft>
+                <a:spcPts val="1117"/>
+              </a:spcAft>
+              <a:defRPr sz="2100">
+                <a:solidFill>
+                  <a:srgbClr val="232323"/>
+                </a:solidFill>
+                <a:latin typeface="Aptos"/>
+              </a:defRPr>
+            </a:pPr>
+            <a:r>
+              <a:rPr sz="2800"/>
+              <a:t>4. Train a muscle-actuated reinforcement-learning controller to reproduce the motion over the reconstructed terrain.</a:t>
+            </a:r>
+          </a:p>
+        </p:txBody>
+      </p:sp>
+      <p:pic>
+        <p:nvPicPr>
+          <p:cNvPr id="14" name="Picture 13">
+            <a:extLst>
+              <a:ext uri="{FF2B5EF4-FFF2-40B4-BE49-F238E27FC236}">
+                <a16:creationId xmlns:a16="http://schemas.microsoft.com/office/drawing/2014/main" id="{B5BFA89A-1689-1F90-397A-23849FB0D41F}"/>
+              </a:ext>
+            </a:extLst>
+          </p:cNvPr>
+          <p:cNvPicPr>
+            <a:picLocks noChangeAspect="1"/>
+          </p:cNvPicPr>
+          <p:nvPr/>
+        </p:nvPicPr>
+        <p:blipFill>
+          <a:blip r:embed="rId2"/>
+          <a:stretch>
+            <a:fillRect/>
+          </a:stretch>
+        </p:blipFill>
+        <p:spPr>
+          <a:xfrm>
+            <a:off x="1635785" y="6081159"/>
+            <a:ext cx="11854130" cy="3893693"/>
+          </a:xfrm>
+          <a:prstGeom prst="rect">
+            <a:avLst/>
+          </a:prstGeom>
+        </p:spPr>
+      </p:pic>
+    </p:spTree>
+  </p:cSld>
+  <p:clrMapOvr>
+    <a:masterClrMapping/>
+  </p:clrMapOvr>
+</p:sld>
+</file>
+
 <file path=ppt/theme/theme1.xml><?xml version="1.0" encoding="utf-8"?>
 <a:theme xmlns:a="http://schemas.openxmlformats.org/drawingml/2006/main" name="Office Theme">
   <a:themeElements>

</xml_diff>